<commit_message>
Refresh recreation demos: master media + AUDIT.md per deck
Regenerated demo.m inventories after group/master extraction polish.
</commit_message>
<xml_diff>
--- a/examples/recreations/01_Box_Conferences__SLG_Intro4Scientists/out_mat2ppt.pptx
+++ b/examples/recreations/01_Box_Conferences__SLG_Intro4Scientists/out_mat2ppt.pptx
@@ -3101,8 +3101,8 @@
         </p:nvSpPr>
         <p:spPr>
           <a:xfrm>
-            <a:off x="457200" y="1295400"/>
-            <a:ext cx="8229600" cy="4830763"/>
+            <a:off x="838200" y="365125"/>
+            <a:ext cx="10515600" cy="1325563"/>
           </a:xfrm>
           <a:prstGeom prst="rect">
             <a:avLst/>
@@ -3127,7 +3127,124 @@
           <a:lstStyle/>
           <a:p>
             <a:r>
+              <a:t>What Makes a Great Scientist?</a:t>
+            </a:r>
+          </a:p>
+        </p:txBody>
+      </p:sp>
+      <p:sp>
+        <p:nvSpPr>
+          <p:cNvPr id="3" name="Rectangle 2"/>
+          <p:cNvSpPr/>
+          <p:nvPr/>
+        </p:nvSpPr>
+        <p:spPr>
+          <a:xfrm>
+            <a:off x="457200" y="1295400"/>
+            <a:ext cx="8229600" cy="4830763"/>
+          </a:xfrm>
+          <a:prstGeom prst="rect">
+            <a:avLst/>
+          </a:prstGeom>
+        </p:spPr>
+        <p:style>
+          <a:lnRef idx="1">
+            <a:schemeClr val="accent1"/>
+          </a:lnRef>
+          <a:fillRef idx="3">
+            <a:schemeClr val="accent1"/>
+          </a:fillRef>
+          <a:effectRef idx="2">
+            <a:schemeClr val="accent1"/>
+          </a:effectRef>
+          <a:fontRef idx="minor">
+            <a:schemeClr val="lt1"/>
+          </a:fontRef>
+        </p:style>
+        <p:txBody>
+          <a:bodyPr rtlCol="0" anchor="ctr"/>
+          <a:lstStyle/>
+          <a:p>
+            <a:r>
               <a:t>Knowing science and math factsBeing able to solve known scientific problemsBeing able to acquire new data and assemble new theories to expand knowledge and answer specific questions about the universeIs there something that many of our greatest scientists have in common?Pictures of Newton, Einstein, and FeynmanOverlays of the Bible, Violin, and Congo drums</a:t>
+            </a:r>
+          </a:p>
+        </p:txBody>
+      </p:sp>
+      <p:sp>
+        <p:nvSpPr>
+          <p:cNvPr id="4" name="Rectangle 3"/>
+          <p:cNvSpPr/>
+          <p:nvPr/>
+        </p:nvSpPr>
+        <p:spPr>
+          <a:xfrm>
+            <a:off x="838200" y="365125"/>
+            <a:ext cx="10515600" cy="1325563"/>
+          </a:xfrm>
+          <a:prstGeom prst="rect">
+            <a:avLst/>
+          </a:prstGeom>
+        </p:spPr>
+        <p:style>
+          <a:lnRef idx="1">
+            <a:schemeClr val="accent1"/>
+          </a:lnRef>
+          <a:fillRef idx="3">
+            <a:schemeClr val="accent1"/>
+          </a:fillRef>
+          <a:effectRef idx="2">
+            <a:schemeClr val="accent1"/>
+          </a:effectRef>
+          <a:fontRef idx="minor">
+            <a:schemeClr val="lt1"/>
+          </a:fontRef>
+        </p:style>
+        <p:txBody>
+          <a:bodyPr rtlCol="0" anchor="ctr"/>
+          <a:lstStyle/>
+          <a:p>
+            <a:r>
+              <a:t>Lesson 18 Biology 2</a:t>
+            </a:r>
+          </a:p>
+        </p:txBody>
+      </p:sp>
+      <p:sp>
+        <p:nvSpPr>
+          <p:cNvPr id="5" name="Rectangle 4"/>
+          <p:cNvSpPr/>
+          <p:nvPr/>
+        </p:nvSpPr>
+        <p:spPr>
+          <a:xfrm>
+            <a:off x="838200" y="365125"/>
+            <a:ext cx="10515600" cy="1325563"/>
+          </a:xfrm>
+          <a:prstGeom prst="rect">
+            <a:avLst/>
+          </a:prstGeom>
+        </p:spPr>
+        <p:style>
+          <a:lnRef idx="1">
+            <a:schemeClr val="accent1"/>
+          </a:lnRef>
+          <a:fillRef idx="3">
+            <a:schemeClr val="accent1"/>
+          </a:fillRef>
+          <a:effectRef idx="2">
+            <a:schemeClr val="accent1"/>
+          </a:effectRef>
+          <a:fontRef idx="minor">
+            <a:schemeClr val="lt1"/>
+          </a:fontRef>
+        </p:style>
+        <p:txBody>
+          <a:bodyPr rtlCol="0" anchor="ctr"/>
+          <a:lstStyle/>
+          <a:p>
+            <a:r>
+              <a:t>1</a:t>
             </a:r>
           </a:p>
         </p:txBody>
@@ -3353,8 +3470,8 @@
         </p:nvSpPr>
         <p:spPr>
           <a:xfrm>
-            <a:off x="152400" y="5943600"/>
-            <a:ext cx="8763000" cy="646331"/>
+            <a:off x="838200" y="365125"/>
+            <a:ext cx="10515600" cy="1325563"/>
           </a:xfrm>
           <a:prstGeom prst="rect">
             <a:avLst/>
@@ -3379,6 +3496,84 @@
           <a:lstStyle/>
           <a:p>
             <a:r>
+              <a:t>Lesson 18 Biology 2</a:t>
+            </a:r>
+          </a:p>
+        </p:txBody>
+      </p:sp>
+      <p:sp>
+        <p:nvSpPr>
+          <p:cNvPr id="8" name="Rectangle 7"/>
+          <p:cNvSpPr/>
+          <p:nvPr/>
+        </p:nvSpPr>
+        <p:spPr>
+          <a:xfrm>
+            <a:off x="838200" y="365125"/>
+            <a:ext cx="10515600" cy="1325563"/>
+          </a:xfrm>
+          <a:prstGeom prst="rect">
+            <a:avLst/>
+          </a:prstGeom>
+        </p:spPr>
+        <p:style>
+          <a:lnRef idx="1">
+            <a:schemeClr val="accent1"/>
+          </a:lnRef>
+          <a:fillRef idx="3">
+            <a:schemeClr val="accent1"/>
+          </a:fillRef>
+          <a:effectRef idx="2">
+            <a:schemeClr val="accent1"/>
+          </a:effectRef>
+          <a:fontRef idx="minor">
+            <a:schemeClr val="lt1"/>
+          </a:fontRef>
+        </p:style>
+        <p:txBody>
+          <a:bodyPr rtlCol="0" anchor="ctr"/>
+          <a:lstStyle/>
+          <a:p>
+            <a:r>
+              <a:t>2</a:t>
+            </a:r>
+          </a:p>
+        </p:txBody>
+      </p:sp>
+      <p:sp>
+        <p:nvSpPr>
+          <p:cNvPr id="9" name="Rectangle 8"/>
+          <p:cNvSpPr/>
+          <p:nvPr/>
+        </p:nvSpPr>
+        <p:spPr>
+          <a:xfrm>
+            <a:off x="152400" y="5943600"/>
+            <a:ext cx="8763000" cy="646331"/>
+          </a:xfrm>
+          <a:prstGeom prst="rect">
+            <a:avLst/>
+          </a:prstGeom>
+        </p:spPr>
+        <p:style>
+          <a:lnRef idx="1">
+            <a:schemeClr val="accent1"/>
+          </a:lnRef>
+          <a:fillRef idx="3">
+            <a:schemeClr val="accent1"/>
+          </a:fillRef>
+          <a:effectRef idx="2">
+            <a:schemeClr val="accent1"/>
+          </a:effectRef>
+          <a:fontRef idx="minor">
+            <a:schemeClr val="lt1"/>
+          </a:fontRef>
+        </p:style>
+        <p:txBody>
+          <a:bodyPr rtlCol="0" anchor="ctr"/>
+          <a:lstStyle/>
+          <a:p>
+            <a:r>
               <a:t>Reason is this ability to bring together the faculties of logic with the faculties of an intuitive, implicit, embodied understanding of what it means to be alive” –Iain McGilchrist</a:t>
             </a:r>
           </a:p>
@@ -3386,7 +3581,7 @@
       </p:sp>
       <p:sp>
         <p:nvSpPr>
-          <p:cNvPr id="8" name="Rectangle 7"/>
+          <p:cNvPr id="10" name="Rectangle 9"/>
           <p:cNvSpPr/>
           <p:nvPr/>
         </p:nvSpPr>
@@ -3449,8 +3644,8 @@
         </p:nvSpPr>
         <p:spPr>
           <a:xfrm>
-            <a:off x="457200" y="1600200"/>
-            <a:ext cx="8229600" cy="4756150"/>
+            <a:off x="838200" y="365125"/>
+            <a:ext cx="10515600" cy="1325563"/>
           </a:xfrm>
           <a:prstGeom prst="rect">
             <a:avLst/>
@@ -3475,7 +3670,124 @@
           <a:lstStyle/>
           <a:p>
             <a:r>
+              <a:t>Developing the Right-Brain</a:t>
+            </a:r>
+          </a:p>
+        </p:txBody>
+      </p:sp>
+      <p:sp>
+        <p:nvSpPr>
+          <p:cNvPr id="3" name="Rectangle 2"/>
+          <p:cNvSpPr/>
+          <p:nvPr/>
+        </p:nvSpPr>
+        <p:spPr>
+          <a:xfrm>
+            <a:off x="457200" y="1600200"/>
+            <a:ext cx="8229600" cy="4756150"/>
+          </a:xfrm>
+          <a:prstGeom prst="rect">
+            <a:avLst/>
+          </a:prstGeom>
+        </p:spPr>
+        <p:style>
+          <a:lnRef idx="1">
+            <a:schemeClr val="accent1"/>
+          </a:lnRef>
+          <a:fillRef idx="3">
+            <a:schemeClr val="accent1"/>
+          </a:fillRef>
+          <a:effectRef idx="2">
+            <a:schemeClr val="accent1"/>
+          </a:effectRef>
+          <a:fontRef idx="minor">
+            <a:schemeClr val="lt1"/>
+          </a:fontRef>
+        </p:style>
+        <p:txBody>
+          <a:bodyPr rtlCol="0" anchor="ctr"/>
+          <a:lstStyle/>
+          <a:p>
+            <a:r>
               <a:t>If we want to educate students to be world-class scientists, we need to develop and not dismiss right-brain thinkingBoth left and right-brain thinking are critical for breakthrough scienceTeach an understanding of and appreciation for Music, Art, and the SacredFor example: band, drawing, family, and the pledge of allegiance/reveilleThe Saint Luke Guild was founded to bring high quality, physical reproductions of the greatest works of art to students of average meansEnabled by two technological developments from the last 20 yearsThe explosion of high-resolution, digital imagery of the greatest works of art, previously reserved to museum visitorsThe dramatic improvements in low-cost, museum quality photographic printing methods</a:t>
+            </a:r>
+          </a:p>
+        </p:txBody>
+      </p:sp>
+      <p:sp>
+        <p:nvSpPr>
+          <p:cNvPr id="4" name="Rectangle 3"/>
+          <p:cNvSpPr/>
+          <p:nvPr/>
+        </p:nvSpPr>
+        <p:spPr>
+          <a:xfrm>
+            <a:off x="838200" y="365125"/>
+            <a:ext cx="10515600" cy="1325563"/>
+          </a:xfrm>
+          <a:prstGeom prst="rect">
+            <a:avLst/>
+          </a:prstGeom>
+        </p:spPr>
+        <p:style>
+          <a:lnRef idx="1">
+            <a:schemeClr val="accent1"/>
+          </a:lnRef>
+          <a:fillRef idx="3">
+            <a:schemeClr val="accent1"/>
+          </a:fillRef>
+          <a:effectRef idx="2">
+            <a:schemeClr val="accent1"/>
+          </a:effectRef>
+          <a:fontRef idx="minor">
+            <a:schemeClr val="lt1"/>
+          </a:fontRef>
+        </p:style>
+        <p:txBody>
+          <a:bodyPr rtlCol="0" anchor="ctr"/>
+          <a:lstStyle/>
+          <a:p>
+            <a:r>
+              <a:t>Lesson 18 Biology 2</a:t>
+            </a:r>
+          </a:p>
+        </p:txBody>
+      </p:sp>
+      <p:sp>
+        <p:nvSpPr>
+          <p:cNvPr id="5" name="Rectangle 4"/>
+          <p:cNvSpPr/>
+          <p:nvPr/>
+        </p:nvSpPr>
+        <p:spPr>
+          <a:xfrm>
+            <a:off x="838200" y="365125"/>
+            <a:ext cx="10515600" cy="1325563"/>
+          </a:xfrm>
+          <a:prstGeom prst="rect">
+            <a:avLst/>
+          </a:prstGeom>
+        </p:spPr>
+        <p:style>
+          <a:lnRef idx="1">
+            <a:schemeClr val="accent1"/>
+          </a:lnRef>
+          <a:fillRef idx="3">
+            <a:schemeClr val="accent1"/>
+          </a:fillRef>
+          <a:effectRef idx="2">
+            <a:schemeClr val="accent1"/>
+          </a:effectRef>
+          <a:fontRef idx="minor">
+            <a:schemeClr val="lt1"/>
+          </a:fontRef>
+        </p:style>
+        <p:txBody>
+          <a:bodyPr rtlCol="0" anchor="ctr"/>
+          <a:lstStyle/>
+          <a:p>
+            <a:r>
+              <a:t>3</a:t>
             </a:r>
           </a:p>
         </p:txBody>
@@ -3498,6 +3810,162 @@
         <p:nvPr/>
       </p:nvGrpSpPr>
       <p:grpSpPr/>
+      <p:sp>
+        <p:nvSpPr>
+          <p:cNvPr id="2" name="Rectangle 1"/>
+          <p:cNvSpPr/>
+          <p:nvPr/>
+        </p:nvSpPr>
+        <p:spPr>
+          <a:xfrm>
+            <a:off x="838200" y="365125"/>
+            <a:ext cx="10515600" cy="1325563"/>
+          </a:xfrm>
+          <a:prstGeom prst="rect">
+            <a:avLst/>
+          </a:prstGeom>
+        </p:spPr>
+        <p:style>
+          <a:lnRef idx="1">
+            <a:schemeClr val="accent1"/>
+          </a:lnRef>
+          <a:fillRef idx="3">
+            <a:schemeClr val="accent1"/>
+          </a:fillRef>
+          <a:effectRef idx="2">
+            <a:schemeClr val="accent1"/>
+          </a:effectRef>
+          <a:fontRef idx="minor">
+            <a:schemeClr val="lt1"/>
+          </a:fontRef>
+        </p:style>
+        <p:txBody>
+          <a:bodyPr rtlCol="0" anchor="ctr"/>
+          <a:lstStyle/>
+          <a:p>
+            <a:r>
+              <a:t>Example Project</a:t>
+            </a:r>
+          </a:p>
+        </p:txBody>
+      </p:sp>
+      <p:sp>
+        <p:nvSpPr>
+          <p:cNvPr id="3" name="Rectangle 2"/>
+          <p:cNvSpPr/>
+          <p:nvPr/>
+        </p:nvSpPr>
+        <p:spPr>
+          <a:xfrm>
+            <a:off x="838200" y="365125"/>
+            <a:ext cx="10515600" cy="1325563"/>
+          </a:xfrm>
+          <a:prstGeom prst="rect">
+            <a:avLst/>
+          </a:prstGeom>
+        </p:spPr>
+        <p:style>
+          <a:lnRef idx="1">
+            <a:schemeClr val="accent1"/>
+          </a:lnRef>
+          <a:fillRef idx="3">
+            <a:schemeClr val="accent1"/>
+          </a:fillRef>
+          <a:effectRef idx="2">
+            <a:schemeClr val="accent1"/>
+          </a:effectRef>
+          <a:fontRef idx="minor">
+            <a:schemeClr val="lt1"/>
+          </a:fontRef>
+        </p:style>
+        <p:txBody>
+          <a:bodyPr rtlCol="0" anchor="ctr"/>
+          <a:lstStyle/>
+          <a:p>
+            <a:r>
+              <a:t>Bring around 50 paintings showing both a timeline of art and world history to Holy Child Catholic School$30k in artwork installed in the last 1.5 years$30k in funding promised by donors to complete the hallwayOver 20 years projects of a similar scale could be done in every school throughout the country for ~.05% of their budgetCompare with Zuckerberg’s $300,000,000 donation to one school district – Zero improvement in student achievement</a:t>
+            </a:r>
+          </a:p>
+        </p:txBody>
+      </p:sp>
+      <p:sp>
+        <p:nvSpPr>
+          <p:cNvPr id="4" name="Rectangle 3"/>
+          <p:cNvSpPr/>
+          <p:nvPr/>
+        </p:nvSpPr>
+        <p:spPr>
+          <a:xfrm>
+            <a:off x="838200" y="365125"/>
+            <a:ext cx="10515600" cy="1325563"/>
+          </a:xfrm>
+          <a:prstGeom prst="rect">
+            <a:avLst/>
+          </a:prstGeom>
+        </p:spPr>
+        <p:style>
+          <a:lnRef idx="1">
+            <a:schemeClr val="accent1"/>
+          </a:lnRef>
+          <a:fillRef idx="3">
+            <a:schemeClr val="accent1"/>
+          </a:fillRef>
+          <a:effectRef idx="2">
+            <a:schemeClr val="accent1"/>
+          </a:effectRef>
+          <a:fontRef idx="minor">
+            <a:schemeClr val="lt1"/>
+          </a:fontRef>
+        </p:style>
+        <p:txBody>
+          <a:bodyPr rtlCol="0" anchor="ctr"/>
+          <a:lstStyle/>
+          <a:p>
+            <a:r>
+              <a:t>Lesson 18 Biology 2</a:t>
+            </a:r>
+          </a:p>
+        </p:txBody>
+      </p:sp>
+      <p:sp>
+        <p:nvSpPr>
+          <p:cNvPr id="5" name="Rectangle 4"/>
+          <p:cNvSpPr/>
+          <p:nvPr/>
+        </p:nvSpPr>
+        <p:spPr>
+          <a:xfrm>
+            <a:off x="838200" y="365125"/>
+            <a:ext cx="10515600" cy="1325563"/>
+          </a:xfrm>
+          <a:prstGeom prst="rect">
+            <a:avLst/>
+          </a:prstGeom>
+        </p:spPr>
+        <p:style>
+          <a:lnRef idx="1">
+            <a:schemeClr val="accent1"/>
+          </a:lnRef>
+          <a:fillRef idx="3">
+            <a:schemeClr val="accent1"/>
+          </a:fillRef>
+          <a:effectRef idx="2">
+            <a:schemeClr val="accent1"/>
+          </a:effectRef>
+          <a:fontRef idx="minor">
+            <a:schemeClr val="lt1"/>
+          </a:fontRef>
+        </p:style>
+        <p:txBody>
+          <a:bodyPr rtlCol="0" anchor="ctr"/>
+          <a:lstStyle/>
+          <a:p>
+            <a:r>
+              <a:t>4</a:t>
+            </a:r>
+          </a:p>
+        </p:txBody>
+      </p:sp>
     </p:spTree>
   </p:cSld>
   <p:clrMapOvr>
@@ -3524,8 +3992,8 @@
         </p:nvSpPr>
         <p:spPr>
           <a:xfrm>
-            <a:off x="76200" y="1600200"/>
-            <a:ext cx="8991600" cy="4525963"/>
+            <a:off x="838200" y="365125"/>
+            <a:ext cx="10515600" cy="1325563"/>
           </a:xfrm>
           <a:prstGeom prst="rect">
             <a:avLst/>
@@ -3550,14 +4018,131 @@
           <a:lstStyle/>
           <a:p>
             <a:r>
+              <a:t>Example Paintings</a:t>
+            </a:r>
+          </a:p>
+        </p:txBody>
+      </p:sp>
+      <p:sp>
+        <p:nvSpPr>
+          <p:cNvPr id="3" name="Rectangle 2"/>
+          <p:cNvSpPr/>
+          <p:nvPr/>
+        </p:nvSpPr>
+        <p:spPr>
+          <a:xfrm>
+            <a:off x="76200" y="1600200"/>
+            <a:ext cx="8991600" cy="4525963"/>
+          </a:xfrm>
+          <a:prstGeom prst="rect">
+            <a:avLst/>
+          </a:prstGeom>
+        </p:spPr>
+        <p:style>
+          <a:lnRef idx="1">
+            <a:schemeClr val="accent1"/>
+          </a:lnRef>
+          <a:fillRef idx="3">
+            <a:schemeClr val="accent1"/>
+          </a:fillRef>
+          <a:effectRef idx="2">
+            <a:schemeClr val="accent1"/>
+          </a:effectRef>
+          <a:fontRef idx="minor">
+            <a:schemeClr val="lt1"/>
+          </a:fontRef>
+        </p:style>
+        <p:txBody>
+          <a:bodyPr rtlCol="0" anchor="ctr"/>
+          <a:lstStyle/>
+          <a:p>
+            <a:r>
               <a:t>Science brings us facts about the world</a:t>
+            </a:r>
+          </a:p>
+        </p:txBody>
+      </p:sp>
+      <p:sp>
+        <p:nvSpPr>
+          <p:cNvPr id="4" name="Rectangle 3"/>
+          <p:cNvSpPr/>
+          <p:nvPr/>
+        </p:nvSpPr>
+        <p:spPr>
+          <a:xfrm>
+            <a:off x="838200" y="365125"/>
+            <a:ext cx="10515600" cy="1325563"/>
+          </a:xfrm>
+          <a:prstGeom prst="rect">
+            <a:avLst/>
+          </a:prstGeom>
+        </p:spPr>
+        <p:style>
+          <a:lnRef idx="1">
+            <a:schemeClr val="accent1"/>
+          </a:lnRef>
+          <a:fillRef idx="3">
+            <a:schemeClr val="accent1"/>
+          </a:fillRef>
+          <a:effectRef idx="2">
+            <a:schemeClr val="accent1"/>
+          </a:effectRef>
+          <a:fontRef idx="minor">
+            <a:schemeClr val="lt1"/>
+          </a:fontRef>
+        </p:style>
+        <p:txBody>
+          <a:bodyPr rtlCol="0" anchor="ctr"/>
+          <a:lstStyle/>
+          <a:p>
+            <a:r>
+              <a:t>Lesson 18 Biology 2</a:t>
+            </a:r>
+          </a:p>
+        </p:txBody>
+      </p:sp>
+      <p:sp>
+        <p:nvSpPr>
+          <p:cNvPr id="5" name="Rectangle 4"/>
+          <p:cNvSpPr/>
+          <p:nvPr/>
+        </p:nvSpPr>
+        <p:spPr>
+          <a:xfrm>
+            <a:off x="838200" y="365125"/>
+            <a:ext cx="10515600" cy="1325563"/>
+          </a:xfrm>
+          <a:prstGeom prst="rect">
+            <a:avLst/>
+          </a:prstGeom>
+        </p:spPr>
+        <p:style>
+          <a:lnRef idx="1">
+            <a:schemeClr val="accent1"/>
+          </a:lnRef>
+          <a:fillRef idx="3">
+            <a:schemeClr val="accent1"/>
+          </a:fillRef>
+          <a:effectRef idx="2">
+            <a:schemeClr val="accent1"/>
+          </a:effectRef>
+          <a:fontRef idx="minor">
+            <a:schemeClr val="lt1"/>
+          </a:fontRef>
+        </p:style>
+        <p:txBody>
+          <a:bodyPr rtlCol="0" anchor="ctr"/>
+          <a:lstStyle/>
+          <a:p>
+            <a:r>
+              <a:t>5</a:t>
             </a:r>
           </a:p>
         </p:txBody>
       </p:sp>
       <p:pic>
         <p:nvPicPr>
-          <p:cNvPr id="3" name="Picture 2" descr="image1.jpg"/>
+          <p:cNvPr id="6" name="Picture 5" descr="image1.jpg"/>
           <p:cNvPicPr>
             <a:picLocks noChangeAspect="1"/>
           </p:cNvPicPr>
@@ -3581,7 +4166,7 @@
       </p:pic>
       <p:pic>
         <p:nvPicPr>
-          <p:cNvPr id="4" name="Picture 3" descr="image2.jpg"/>
+          <p:cNvPr id="7" name="Picture 6" descr="image2.jpg"/>
           <p:cNvPicPr>
             <a:picLocks noChangeAspect="1"/>
           </p:cNvPicPr>
@@ -3629,8 +4214,8 @@
         </p:nvSpPr>
         <p:spPr>
           <a:xfrm>
-            <a:off x="76200" y="1600200"/>
-            <a:ext cx="8991600" cy="4525963"/>
+            <a:off x="838200" y="365125"/>
+            <a:ext cx="10515600" cy="1325563"/>
           </a:xfrm>
           <a:prstGeom prst="rect">
             <a:avLst/>
@@ -3655,7 +4240,124 @@
           <a:lstStyle/>
           <a:p>
             <a:r>
+              <a:t>Summary</a:t>
+            </a:r>
+          </a:p>
+        </p:txBody>
+      </p:sp>
+      <p:sp>
+        <p:nvSpPr>
+          <p:cNvPr id="3" name="Rectangle 2"/>
+          <p:cNvSpPr/>
+          <p:nvPr/>
+        </p:nvSpPr>
+        <p:spPr>
+          <a:xfrm>
+            <a:off x="76200" y="1600200"/>
+            <a:ext cx="8991600" cy="4525963"/>
+          </a:xfrm>
+          <a:prstGeom prst="rect">
+            <a:avLst/>
+          </a:prstGeom>
+        </p:spPr>
+        <p:style>
+          <a:lnRef idx="1">
+            <a:schemeClr val="accent1"/>
+          </a:lnRef>
+          <a:fillRef idx="3">
+            <a:schemeClr val="accent1"/>
+          </a:fillRef>
+          <a:effectRef idx="2">
+            <a:schemeClr val="accent1"/>
+          </a:effectRef>
+          <a:fontRef idx="minor">
+            <a:schemeClr val="lt1"/>
+          </a:fontRef>
+        </p:style>
+        <p:txBody>
+          <a:bodyPr rtlCol="0" anchor="ctr"/>
+          <a:lstStyle/>
+          <a:p>
+            <a:r>
               <a:t>Science brings us disembodied, decontextualized facts about the worldArt and myth are focused on how embodied humans should act in the real world, which is particular and uncertainBoth left and right-brained thinking is necessary for a world-class scientific enterpriseThe scientist is servant to the humanities majorThey control how our inventions are usedThe Saint Luke Guild helps develop right-brain thinking by bringing high quality reproductions of the greatest works of art in the Western Canon to average studentsDeveloping an appreciation for rapt attention alongside clinical attention</a:t>
+            </a:r>
+          </a:p>
+        </p:txBody>
+      </p:sp>
+      <p:sp>
+        <p:nvSpPr>
+          <p:cNvPr id="4" name="Rectangle 3"/>
+          <p:cNvSpPr/>
+          <p:nvPr/>
+        </p:nvSpPr>
+        <p:spPr>
+          <a:xfrm>
+            <a:off x="838200" y="365125"/>
+            <a:ext cx="10515600" cy="1325563"/>
+          </a:xfrm>
+          <a:prstGeom prst="rect">
+            <a:avLst/>
+          </a:prstGeom>
+        </p:spPr>
+        <p:style>
+          <a:lnRef idx="1">
+            <a:schemeClr val="accent1"/>
+          </a:lnRef>
+          <a:fillRef idx="3">
+            <a:schemeClr val="accent1"/>
+          </a:fillRef>
+          <a:effectRef idx="2">
+            <a:schemeClr val="accent1"/>
+          </a:effectRef>
+          <a:fontRef idx="minor">
+            <a:schemeClr val="lt1"/>
+          </a:fontRef>
+        </p:style>
+        <p:txBody>
+          <a:bodyPr rtlCol="0" anchor="ctr"/>
+          <a:lstStyle/>
+          <a:p>
+            <a:r>
+              <a:t>Lesson 18 Biology 2</a:t>
+            </a:r>
+          </a:p>
+        </p:txBody>
+      </p:sp>
+      <p:sp>
+        <p:nvSpPr>
+          <p:cNvPr id="5" name="Rectangle 4"/>
+          <p:cNvSpPr/>
+          <p:nvPr/>
+        </p:nvSpPr>
+        <p:spPr>
+          <a:xfrm>
+            <a:off x="838200" y="365125"/>
+            <a:ext cx="10515600" cy="1325563"/>
+          </a:xfrm>
+          <a:prstGeom prst="rect">
+            <a:avLst/>
+          </a:prstGeom>
+        </p:spPr>
+        <p:style>
+          <a:lnRef idx="1">
+            <a:schemeClr val="accent1"/>
+          </a:lnRef>
+          <a:fillRef idx="3">
+            <a:schemeClr val="accent1"/>
+          </a:fillRef>
+          <a:effectRef idx="2">
+            <a:schemeClr val="accent1"/>
+          </a:effectRef>
+          <a:fontRef idx="minor">
+            <a:schemeClr val="lt1"/>
+          </a:fontRef>
+        </p:style>
+        <p:txBody>
+          <a:bodyPr rtlCol="0" anchor="ctr"/>
+          <a:lstStyle/>
+          <a:p>
+            <a:r>
+              <a:t>6</a:t>
             </a:r>
           </a:p>
         </p:txBody>

</xml_diff>